<commit_message>
Session 3 (How AI is made) as PowerPoint; workflow deck moved to Session 5; Session 2 points to new Session 3
Co-Authored-By: Claude Opus 5.5 <noreply@anthropic.com>
</commit_message>
<xml_diff>
--- a/session-2/AEPA-Session-2.pptx
+++ b/session-2/AEPA-Session-2.pptx
@@ -124,21 +124,21 @@
   <p:extLst>
     <p:ext uri="{521415D9-36F7-43E2-AB2F-B90AF26B5E84}">
       <p14:sectionLst xmlns:p14="http://schemas.microsoft.com/office/powerpoint/2010/main">
-        <p14:section name="Intro" id="{52e454aa-3233-38c3-a566-331322f69795}">
+        <p14:section name="Intro" id="{5477243a-cebe-c3c6-61ee-4fe6001de2fe}">
           <p14:sldIdLst>
             <p14:sldId id="256"/>
             <p14:sldId id="257"/>
             <p14:sldId id="258"/>
           </p14:sldIdLst>
         </p14:section>
-        <p14:section name="How AI reads" id="{90aff00e-56e2-34fd-dbb4-c7eb42949274}">
+        <p14:section name="How AI reads" id="{04ae6388-85a6-af03-d28e-3a5da97a1a86}">
           <p14:sldIdLst>
             <p14:sldId id="259"/>
             <p14:sldId id="260"/>
             <p14:sldId id="261"/>
           </p14:sldIdLst>
         </p14:section>
-        <p14:section name="Why answers change" id="{b590aa46-5e89-89cf-19e0-0dc7912d7d6a}">
+        <p14:section name="Why answers change" id="{65d0e45b-a96b-bf28-fbc7-465c8dcf8490}">
           <p14:sldIdLst>
             <p14:sldId id="262"/>
             <p14:sldId id="263"/>
@@ -146,25 +146,25 @@
             <p14:sldId id="265"/>
           </p14:sldIdLst>
         </p14:section>
-        <p14:section name="Trust, but verify" id="{6ed2b714-37d6-aa08-cce3-e8b2fe82e14c}">
+        <p14:section name="Trust, but verify" id="{6acfd6c8-f8b9-b846-2acf-047726e25e2f}">
           <p14:sldIdLst>
             <p14:sldId id="266"/>
             <p14:sldId id="267"/>
           </p14:sldIdLst>
         </p14:section>
-        <p14:section name="Learn with AI" id="{5ce58789-316b-85e8-cf74-0f2fd24782c7}">
+        <p14:section name="Learn with AI" id="{2f37017b-9c28-114e-3be4-b359deadaf3b}">
           <p14:sldIdLst>
             <p14:sldId id="268"/>
             <p14:sldId id="269"/>
           </p14:sldIdLst>
         </p14:section>
-        <p14:section name="Safe and honest" id="{a83c6e49-6ec9-01f8-0a5c-218c3bff2699}">
+        <p14:section name="Safe and honest" id="{c7f1ad58-9505-88c5-9c52-c25990f8e525}">
           <p14:sldIdLst>
             <p14:sldId id="270"/>
             <p14:sldId id="271"/>
           </p14:sldIdLst>
         </p14:section>
-        <p14:section name="Wrap-up" id="{dd39bb81-6496-7389-dc5d-f7ee4cf8a7b0}">
+        <p14:section name="Wrap-up" id="{71ce6b35-7642-3642-3ef2-a5e5aba1f696}">
           <p14:sldIdLst>
             <p14:sldId id="272"/>
             <p14:sldId id="273"/>
@@ -1405,9 +1405,9 @@
             <a:r>
               <a:rPr lang="en-US" dirty="0"/>
               <a:t>[~1:00]
-Дараагийн удаа, 3-р хичээл: prompt-оос workflow руу. AI яаж боддогийг ойлгочихсон болохоор одоо түүгээр бүтээнэ. Бүтэн долоо хоногийн контент гаргадаг систем хийгээд, тэрийг жинхэнэ бизнест яаж санал болгохыг үзнэ.
+Дараагийн удаа, 3-р хичээл: AI яаж бүтдэг вэ. Энэ удаа лаборатори шиг өдөр болно. Өөрсдөө жижиг AI сургана, AI утгыг яаж хадгалдгийг харна, шуугианаас зураг яаж гардгийг үзнэ, тэгээд нэг ботыг хакердах гэж оролдоно.
 [Эхэнд тэмдэглэсэн 'яагаад'-уудыг эргэж хар. Хариулагдаагүй нь байвал хурдан хариул эсвэл дараагийн хичээлд үлдээ.]
-Эхлээд ойлго, тэгээд бүтээ. #showcase дээр уулзъя. Баярлалаа!</a:t>
+Ноутбуктай бол авчраарай. #showcase дээр уулзъя. Баярлалаа!</a:t>
             </a:r>
             <a:endParaRPr lang="en-US" dirty="0"/>
           </a:p>
@@ -9698,7 +9698,7 @@
                 <a:ea typeface="Arial" pitchFamily="34" charset="-122"/>
                 <a:cs typeface="Arial" pitchFamily="34" charset="-120"/>
               </a:rPr>
-              <a:t>Session 3: From prompt to workflow</a:t>
+              <a:t>Session 3: How AI is made</a:t>
             </a:r>
             <a:endParaRPr lang="en-US" sz="3400" dirty="0"/>
           </a:p>
@@ -9734,7 +9734,7 @@
                   <a:schemeClr val="tx2"/>
                 </a:solidFill>
               </a:rPr>
-              <a:t>Now that you know how AI thinks, we build with it: a reusable system that produces a full week of content, and how to offer it to a real business.</a:t>
+              <a:t>Lab day. We open the machine: train your own model, map how AI stores meaning, turn noise into an image, and try to hack a bot.</a:t>
             </a:r>
             <a:endParaRPr lang="en-US" sz="1800" dirty="0"/>
           </a:p>
@@ -9749,7 +9749,7 @@
         <p:spPr>
           <a:xfrm>
             <a:off x="685800" y="3429000"/>
-            <a:ext cx="1650949" cy="1097280"/>
+            <a:ext cx="2533574" cy="1097280"/>
           </a:xfrm>
           <a:prstGeom prst="roundRect">
             <a:avLst>
@@ -9814,7 +9814,7 @@
         <p:spPr>
           <a:xfrm>
             <a:off x="905256" y="4178808"/>
-            <a:ext cx="1212037" cy="384048"/>
+            <a:ext cx="2094662" cy="384048"/>
           </a:xfrm>
           <a:prstGeom prst="rect">
             <a:avLst/>
@@ -9830,7 +9830,7 @@
               <a:buNone/>
             </a:pPr>
             <a:r>
-              <a:rPr lang="en-US" sz="1400" b="1" dirty="0">
+              <a:rPr lang="en-US" sz="1500" b="1" dirty="0">
                 <a:solidFill>
                   <a:schemeClr val="tx1"/>
                 </a:solidFill>
@@ -9838,9 +9838,9 @@
                 <a:ea typeface="Arial" pitchFamily="34" charset="-122"/>
                 <a:cs typeface="Arial" pitchFamily="34" charset="-120"/>
               </a:rPr>
-              <a:t>Context pack</a:t>
-            </a:r>
-            <a:endParaRPr lang="en-US" sz="1400" dirty="0"/>
+              <a:t>Train a model</a:t>
+            </a:r>
+            <a:endParaRPr lang="en-US" sz="1500" dirty="0"/>
           </a:p>
         </p:txBody>
       </p:sp>
@@ -9852,8 +9852,8 @@
         </p:nvSpPr>
         <p:spPr>
           <a:xfrm>
-            <a:off x="2519629" y="3429000"/>
-            <a:ext cx="1650949" cy="1097280"/>
+            <a:off x="3447974" y="3429000"/>
+            <a:ext cx="2533574" cy="1097280"/>
           </a:xfrm>
           <a:prstGeom prst="roundRect">
             <a:avLst>
@@ -9879,7 +9879,7 @@
         </p:nvSpPr>
         <p:spPr>
           <a:xfrm>
-            <a:off x="2739085" y="3648456"/>
+            <a:off x="3667430" y="3648456"/>
             <a:ext cx="420624" cy="420624"/>
           </a:xfrm>
           <a:prstGeom prst="ellipse">
@@ -9917,8 +9917,8 @@
         </p:nvSpPr>
         <p:spPr>
           <a:xfrm>
-            <a:off x="2739085" y="4178808"/>
-            <a:ext cx="1212037" cy="384048"/>
+            <a:off x="3667430" y="4178808"/>
+            <a:ext cx="2094662" cy="384048"/>
           </a:xfrm>
           <a:prstGeom prst="rect">
             <a:avLst/>
@@ -9934,7 +9934,7 @@
               <a:buNone/>
             </a:pPr>
             <a:r>
-              <a:rPr lang="en-US" sz="1400" b="1" dirty="0">
+              <a:rPr lang="en-US" sz="1500" b="1" dirty="0">
                 <a:solidFill>
                   <a:schemeClr val="tx1"/>
                 </a:solidFill>
@@ -9942,9 +9942,9 @@
                 <a:ea typeface="Arial" pitchFamily="34" charset="-122"/>
                 <a:cs typeface="Arial" pitchFamily="34" charset="-120"/>
               </a:rPr>
-              <a:t>Plan the week</a:t>
-            </a:r>
-            <a:endParaRPr lang="en-US" sz="1400" dirty="0"/>
+              <a:t>Map meaning</a:t>
+            </a:r>
+            <a:endParaRPr lang="en-US" sz="1500" dirty="0"/>
           </a:p>
         </p:txBody>
       </p:sp>
@@ -9956,8 +9956,8 @@
         </p:nvSpPr>
         <p:spPr>
           <a:xfrm>
-            <a:off x="4353458" y="3429000"/>
-            <a:ext cx="1650949" cy="1097280"/>
+            <a:off x="6210148" y="3429000"/>
+            <a:ext cx="2533574" cy="1097280"/>
           </a:xfrm>
           <a:prstGeom prst="roundRect">
             <a:avLst>
@@ -9983,7 +9983,7 @@
         </p:nvSpPr>
         <p:spPr>
           <a:xfrm>
-            <a:off x="4572914" y="3648456"/>
+            <a:off x="6429604" y="3648456"/>
             <a:ext cx="420624" cy="420624"/>
           </a:xfrm>
           <a:prstGeom prst="ellipse">
@@ -10021,8 +10021,8 @@
         </p:nvSpPr>
         <p:spPr>
           <a:xfrm>
-            <a:off x="4572914" y="4178808"/>
-            <a:ext cx="1212037" cy="384048"/>
+            <a:off x="6429604" y="4178808"/>
+            <a:ext cx="2094662" cy="384048"/>
           </a:xfrm>
           <a:prstGeom prst="rect">
             <a:avLst/>
@@ -10038,7 +10038,7 @@
               <a:buNone/>
             </a:pPr>
             <a:r>
-              <a:rPr lang="en-US" sz="1400" b="1" dirty="0">
+              <a:rPr lang="en-US" sz="1500" b="1" dirty="0">
                 <a:solidFill>
                   <a:schemeClr val="tx1"/>
                 </a:solidFill>
@@ -10046,9 +10046,9 @@
                 <a:ea typeface="Arial" pitchFamily="34" charset="-122"/>
                 <a:cs typeface="Arial" pitchFamily="34" charset="-120"/>
               </a:rPr>
-              <a:t>Write 7 posts</a:t>
-            </a:r>
-            <a:endParaRPr lang="en-US" sz="1400" dirty="0"/>
+              <a:t>Noise to image</a:t>
+            </a:r>
+            <a:endParaRPr lang="en-US" sz="1500" dirty="0"/>
           </a:p>
         </p:txBody>
       </p:sp>
@@ -10060,8 +10060,8 @@
         </p:nvSpPr>
         <p:spPr>
           <a:xfrm>
-            <a:off x="6187288" y="3429000"/>
-            <a:ext cx="1650949" cy="1097280"/>
+            <a:off x="8972321" y="3429000"/>
+            <a:ext cx="2533574" cy="1097280"/>
           </a:xfrm>
           <a:prstGeom prst="roundRect">
             <a:avLst>
@@ -10087,7 +10087,7 @@
         </p:nvSpPr>
         <p:spPr>
           <a:xfrm>
-            <a:off x="6406744" y="3648456"/>
+            <a:off x="9191777" y="3648456"/>
             <a:ext cx="420624" cy="420624"/>
           </a:xfrm>
           <a:prstGeom prst="ellipse">
@@ -10125,8 +10125,8 @@
         </p:nvSpPr>
         <p:spPr>
           <a:xfrm>
-            <a:off x="6406744" y="4178808"/>
-            <a:ext cx="1212037" cy="384048"/>
+            <a:off x="9191777" y="4178808"/>
+            <a:ext cx="2094662" cy="384048"/>
           </a:xfrm>
           <a:prstGeom prst="rect">
             <a:avLst/>
@@ -10142,7 +10142,7 @@
               <a:buNone/>
             </a:pPr>
             <a:r>
-              <a:rPr lang="en-US" sz="1400" b="1" dirty="0">
+              <a:rPr lang="en-US" sz="1500" b="1" dirty="0">
                 <a:solidFill>
                   <a:schemeClr val="tx1"/>
                 </a:solidFill>
@@ -10150,103 +10150,38 @@
                 <a:ea typeface="Arial" pitchFamily="34" charset="-122"/>
                 <a:cs typeface="Arial" pitchFamily="34" charset="-120"/>
               </a:rPr>
-              <a:t>Make images</a:t>
-            </a:r>
-            <a:endParaRPr lang="en-US" sz="1400" dirty="0"/>
-          </a:p>
-        </p:txBody>
-      </p:sp>
-      <p:sp>
-        <p:nvSpPr>
-          <p:cNvPr id="18" name="card-211"/>
-          <p:cNvSpPr/>
-          <p:nvPr/>
-        </p:nvSpPr>
-        <p:spPr>
-          <a:xfrm>
-            <a:off x="8021117" y="3429000"/>
-            <a:ext cx="1650949" cy="1097280"/>
-          </a:xfrm>
-          <a:prstGeom prst="roundRect">
-            <a:avLst>
-              <a:gd name="adj" fmla="val 6667"/>
-            </a:avLst>
-          </a:prstGeom>
-          <a:solidFill>
-            <a:schemeClr val="bg1"/>
-          </a:solidFill>
-          <a:ln w="12700">
-            <a:solidFill>
-              <a:schemeClr val="bg1"/>
-            </a:solidFill>
-            <a:prstDash val="solid"/>
-          </a:ln>
-        </p:spPr>
-      </p:sp>
-      <p:sp>
-        <p:nvSpPr>
-          <p:cNvPr id="19" name="num-212"/>
+              <a:t>Hack the bot</a:t>
+            </a:r>
+            <a:endParaRPr lang="en-US" sz="1500" dirty="0"/>
+          </a:p>
+        </p:txBody>
+      </p:sp>
+      <p:sp>
+        <p:nvSpPr>
+          <p:cNvPr id="18" name="statement-211"/>
           <p:cNvSpPr txBox="1"/>
           <p:nvPr/>
         </p:nvSpPr>
         <p:spPr>
           <a:xfrm>
-            <a:off x="8240573" y="3648456"/>
-            <a:ext cx="420624" cy="420624"/>
-          </a:xfrm>
-          <a:prstGeom prst="ellipse">
-            <a:avLst/>
-          </a:prstGeom>
-          <a:solidFill>
-            <a:schemeClr val="accent1"/>
-          </a:solidFill>
+            <a:off x="685800" y="5074920"/>
+            <a:ext cx="10820095" cy="548640"/>
+          </a:xfrm>
+          <a:prstGeom prst="rect">
+            <a:avLst/>
+          </a:prstGeom>
+          <a:noFill/>
           <a:ln/>
         </p:spPr>
         <p:txBody>
           <a:bodyPr wrap="square" lIns="0" tIns="0" rIns="0" bIns="0" rtlCol="0" anchor="ctr"/>
           <a:lstStyle/>
           <a:p>
-            <a:pPr algn="ctr" indent="0" marL="0">
-              <a:buNone/>
-            </a:pPr>
-            <a:r>
-              <a:rPr lang="en-US" sz="1400" b="1" dirty="0">
-                <a:solidFill>
-                  <a:schemeClr val="bg1"/>
-                </a:solidFill>
-              </a:rPr>
-              <a:t>5</a:t>
-            </a:r>
-            <a:endParaRPr lang="en-US" sz="1400" dirty="0"/>
-          </a:p>
-        </p:txBody>
-      </p:sp>
-      <p:sp>
-        <p:nvSpPr>
-          <p:cNvPr id="20" name="card-title-213"/>
-          <p:cNvSpPr txBox="1"/>
-          <p:nvPr/>
-        </p:nvSpPr>
-        <p:spPr>
-          <a:xfrm>
-            <a:off x="8240573" y="4178808"/>
-            <a:ext cx="1212037" cy="384048"/>
-          </a:xfrm>
-          <a:prstGeom prst="rect">
-            <a:avLst/>
-          </a:prstGeom>
-          <a:noFill/>
-          <a:ln/>
-        </p:spPr>
-        <p:txBody>
-          <a:bodyPr wrap="square" lIns="0" tIns="0" rIns="0" bIns="0" rtlCol="0" anchor="t"/>
-          <a:lstStyle/>
-          <a:p>
             <a:pPr indent="0" marL="0">
               <a:buNone/>
             </a:pPr>
             <a:r>
-              <a:rPr lang="en-US" sz="1400" b="1" dirty="0">
+              <a:rPr lang="en-US" sz="2400" b="1" dirty="0">
                 <a:solidFill>
                   <a:schemeClr val="tx1"/>
                 </a:solidFill>
@@ -10254,164 +10189,21 @@
                 <a:ea typeface="Arial" pitchFamily="34" charset="-122"/>
                 <a:cs typeface="Arial" pitchFamily="34" charset="-120"/>
               </a:rPr>
-              <a:t>Check</a:t>
-            </a:r>
-            <a:endParaRPr lang="en-US" sz="1400" dirty="0"/>
-          </a:p>
-        </p:txBody>
-      </p:sp>
-      <p:sp>
-        <p:nvSpPr>
-          <p:cNvPr id="21" name="card-214"/>
-          <p:cNvSpPr/>
-          <p:nvPr/>
-        </p:nvSpPr>
-        <p:spPr>
-          <a:xfrm>
-            <a:off x="9854946" y="3429000"/>
-            <a:ext cx="1650949" cy="1097280"/>
-          </a:xfrm>
-          <a:prstGeom prst="roundRect">
-            <a:avLst>
-              <a:gd name="adj" fmla="val 6667"/>
-            </a:avLst>
-          </a:prstGeom>
-          <a:solidFill>
-            <a:schemeClr val="bg1"/>
-          </a:solidFill>
-          <a:ln w="12700">
-            <a:solidFill>
-              <a:schemeClr val="bg1"/>
-            </a:solidFill>
-            <a:prstDash val="solid"/>
-          </a:ln>
-        </p:spPr>
-      </p:sp>
-      <p:sp>
-        <p:nvSpPr>
-          <p:cNvPr id="22" name="num-215"/>
-          <p:cNvSpPr txBox="1"/>
-          <p:nvPr/>
-        </p:nvSpPr>
-        <p:spPr>
-          <a:xfrm>
-            <a:off x="10074402" y="3648456"/>
-            <a:ext cx="420624" cy="420624"/>
-          </a:xfrm>
-          <a:prstGeom prst="ellipse">
-            <a:avLst/>
-          </a:prstGeom>
-          <a:solidFill>
-            <a:schemeClr val="accent1"/>
-          </a:solidFill>
-          <a:ln/>
-        </p:spPr>
-        <p:txBody>
-          <a:bodyPr wrap="square" lIns="0" tIns="0" rIns="0" bIns="0" rtlCol="0" anchor="ctr"/>
-          <a:lstStyle/>
-          <a:p>
-            <a:pPr algn="ctr" indent="0" marL="0">
-              <a:buNone/>
-            </a:pPr>
-            <a:r>
-              <a:rPr lang="en-US" sz="1400" b="1" dirty="0">
-                <a:solidFill>
-                  <a:schemeClr val="bg1"/>
-                </a:solidFill>
-              </a:rPr>
-              <a:t>6</a:t>
-            </a:r>
-            <a:endParaRPr lang="en-US" sz="1400" dirty="0"/>
-          </a:p>
-        </p:txBody>
-      </p:sp>
-      <p:sp>
-        <p:nvSpPr>
-          <p:cNvPr id="23" name="card-title-216"/>
-          <p:cNvSpPr txBox="1"/>
-          <p:nvPr/>
-        </p:nvSpPr>
-        <p:spPr>
-          <a:xfrm>
-            <a:off x="10074402" y="4178808"/>
-            <a:ext cx="1212037" cy="384048"/>
-          </a:xfrm>
-          <a:prstGeom prst="rect">
-            <a:avLst/>
-          </a:prstGeom>
-          <a:noFill/>
-          <a:ln/>
-        </p:spPr>
-        <p:txBody>
-          <a:bodyPr wrap="square" lIns="0" tIns="0" rIns="0" bIns="0" rtlCol="0" anchor="t"/>
-          <a:lstStyle/>
-          <a:p>
+              <a:t>Train it. Map it. Draw it. </a:t>
+            </a:r>
             <a:pPr indent="0" marL="0">
               <a:buNone/>
             </a:pPr>
             <a:r>
-              <a:rPr lang="en-US" sz="1400" b="1" dirty="0">
-                <a:solidFill>
-                  <a:schemeClr val="tx1"/>
+              <a:rPr lang="en-US" sz="2400" b="1" dirty="0">
+                <a:solidFill>
+                  <a:schemeClr val="accent1"/>
                 </a:solidFill>
                 <a:latin typeface="Arial" pitchFamily="34" charset="0"/>
                 <a:ea typeface="Arial" pitchFamily="34" charset="-122"/>
                 <a:cs typeface="Arial" pitchFamily="34" charset="-120"/>
               </a:rPr>
-              <a:t>Schedule</a:t>
-            </a:r>
-            <a:endParaRPr lang="en-US" sz="1400" dirty="0"/>
-          </a:p>
-        </p:txBody>
-      </p:sp>
-      <p:sp>
-        <p:nvSpPr>
-          <p:cNvPr id="24" name="statement-217"/>
-          <p:cNvSpPr txBox="1"/>
-          <p:nvPr/>
-        </p:nvSpPr>
-        <p:spPr>
-          <a:xfrm>
-            <a:off x="685800" y="5074920"/>
-            <a:ext cx="10820095" cy="548640"/>
-          </a:xfrm>
-          <a:prstGeom prst="rect">
-            <a:avLst/>
-          </a:prstGeom>
-          <a:noFill/>
-          <a:ln/>
-        </p:spPr>
-        <p:txBody>
-          <a:bodyPr wrap="square" lIns="0" tIns="0" rIns="0" bIns="0" rtlCol="0" anchor="ctr"/>
-          <a:lstStyle/>
-          <a:p>
-            <a:pPr indent="0" marL="0">
-              <a:buNone/>
-            </a:pPr>
-            <a:r>
-              <a:rPr lang="en-US" sz="2400" b="1" dirty="0">
-                <a:solidFill>
-                  <a:schemeClr val="tx1"/>
-                </a:solidFill>
-                <a:latin typeface="Arial" pitchFamily="34" charset="0"/>
-                <a:ea typeface="Arial" pitchFamily="34" charset="-122"/>
-                <a:cs typeface="Arial" pitchFamily="34" charset="-120"/>
-              </a:rPr>
-              <a:t>Understand it first. </a:t>
-            </a:r>
-            <a:pPr indent="0" marL="0">
-              <a:buNone/>
-            </a:pPr>
-            <a:r>
-              <a:rPr lang="en-US" sz="2400" b="1" dirty="0">
-                <a:solidFill>
-                  <a:schemeClr val="accent1"/>
-                </a:solidFill>
-                <a:latin typeface="Arial" pitchFamily="34" charset="0"/>
-                <a:ea typeface="Arial" pitchFamily="34" charset="-122"/>
-                <a:cs typeface="Arial" pitchFamily="34" charset="-120"/>
-              </a:rPr>
-              <a:t>Then build with it.</a:t>
+              <a:t>Hack it.</a:t>
             </a:r>
             <a:endParaRPr lang="en-US" sz="2400" dirty="0"/>
           </a:p>

</xml_diff>

<commit_message>
Session 3 replaced with vibe-coding deck (Build, don't just chat); workflow deck is Session 4; Session 2 points to new Session 3
Co-Authored-By: Claude Opus 5.5 <noreply@anthropic.com>
</commit_message>
<xml_diff>
--- a/session-2/AEPA-Session-2.pptx
+++ b/session-2/AEPA-Session-2.pptx
@@ -124,21 +124,21 @@
   <p:extLst>
     <p:ext uri="{521415D9-36F7-43E2-AB2F-B90AF26B5E84}">
       <p14:sectionLst xmlns:p14="http://schemas.microsoft.com/office/powerpoint/2010/main">
-        <p14:section name="Intro" id="{5477243a-cebe-c3c6-61ee-4fe6001de2fe}">
+        <p14:section name="Intro" id="{eaff8a0b-270d-670e-1bac-74ddb0a8b437}">
           <p14:sldIdLst>
             <p14:sldId id="256"/>
             <p14:sldId id="257"/>
             <p14:sldId id="258"/>
           </p14:sldIdLst>
         </p14:section>
-        <p14:section name="How AI reads" id="{04ae6388-85a6-af03-d28e-3a5da97a1a86}">
+        <p14:section name="How AI reads" id="{05e19305-793d-3894-7111-9e9a905681d6}">
           <p14:sldIdLst>
             <p14:sldId id="259"/>
             <p14:sldId id="260"/>
             <p14:sldId id="261"/>
           </p14:sldIdLst>
         </p14:section>
-        <p14:section name="Why answers change" id="{65d0e45b-a96b-bf28-fbc7-465c8dcf8490}">
+        <p14:section name="Why answers change" id="{1e55b0d5-fe7b-997d-a35b-54e87b44847a}">
           <p14:sldIdLst>
             <p14:sldId id="262"/>
             <p14:sldId id="263"/>
@@ -146,25 +146,25 @@
             <p14:sldId id="265"/>
           </p14:sldIdLst>
         </p14:section>
-        <p14:section name="Trust, but verify" id="{6acfd6c8-f8b9-b846-2acf-047726e25e2f}">
+        <p14:section name="Trust, but verify" id="{69fce240-e484-43a0-58f5-d763913dbd07}">
           <p14:sldIdLst>
             <p14:sldId id="266"/>
             <p14:sldId id="267"/>
           </p14:sldIdLst>
         </p14:section>
-        <p14:section name="Learn with AI" id="{2f37017b-9c28-114e-3be4-b359deadaf3b}">
+        <p14:section name="Learn with AI" id="{c956de21-7217-c550-5b8c-0ca930d2b987}">
           <p14:sldIdLst>
             <p14:sldId id="268"/>
             <p14:sldId id="269"/>
           </p14:sldIdLst>
         </p14:section>
-        <p14:section name="Safe and honest" id="{c7f1ad58-9505-88c5-9c52-c25990f8e525}">
+        <p14:section name="Safe and honest" id="{23b78a0e-20f1-4d33-0621-00b6338a2080}">
           <p14:sldIdLst>
             <p14:sldId id="270"/>
             <p14:sldId id="271"/>
           </p14:sldIdLst>
         </p14:section>
-        <p14:section name="Wrap-up" id="{71ce6b35-7642-3642-3ef2-a5e5aba1f696}">
+        <p14:section name="Wrap-up" id="{eee215c7-763f-6108-e30b-77715fd816d5}">
           <p14:sldIdLst>
             <p14:sldId id="272"/>
             <p14:sldId id="273"/>
@@ -1405,9 +1405,9 @@
             <a:r>
               <a:rPr lang="en-US" dirty="0"/>
               <a:t>[~1:00]
-Дараагийн удаа, 3-р хичээл: AI яаж бүтдэг вэ. Энэ удаа лаборатори шиг өдөр болно. Өөрсдөө жижиг AI сургана, AI утгыг яаж хадгалдгийг харна, шуугианаас зураг яаж гардгийг үзнэ, тэгээд нэг ботыг хакердах гэж оролдоно.
+Дараагийн удаа, 3-р хичээл: зүгээр чатлах биш, бүтээх. Код бичихгүйгээр, зүгээр л үгээр тайлбарлаад жинхэнэ тоглоом, вэбсайт хийнэ. Юу бүтээхийг та нар шийднэ.
 [Эхэнд тэмдэглэсэн 'яагаад'-уудыг эргэж хар. Хариулагдаагүй нь байвал хурдан хариул эсвэл дараагийн хичээлд үлдээ.]
-Ноутбуктай бол авчраарай. #showcase дээр уулзъя. Баярлалаа!</a:t>
+#showcase дээр уулзъя. Баярлалаа!</a:t>
             </a:r>
             <a:endParaRPr lang="en-US" dirty="0"/>
           </a:p>
@@ -9698,7 +9698,7 @@
                 <a:ea typeface="Arial" pitchFamily="34" charset="-122"/>
                 <a:cs typeface="Arial" pitchFamily="34" charset="-120"/>
               </a:rPr>
-              <a:t>Session 3: How AI is made</a:t>
+              <a:t>Session 3: Build, don't just chat</a:t>
             </a:r>
             <a:endParaRPr lang="en-US" sz="3400" dirty="0"/>
           </a:p>
@@ -9734,7 +9734,7 @@
                   <a:schemeClr val="tx2"/>
                 </a:solidFill>
               </a:rPr>
-              <a:t>Lab day. We open the machine: train your own model, map how AI stores meaning, turn noise into an image, and try to hack a bot.</a:t>
+              <a:t>We stop chatting and start building: real games and websites, made live just by describing them. You decide what we build.</a:t>
             </a:r>
             <a:endParaRPr lang="en-US" sz="1800" dirty="0"/>
           </a:p>
@@ -9838,7 +9838,7 @@
                 <a:ea typeface="Arial" pitchFamily="34" charset="-122"/>
                 <a:cs typeface="Arial" pitchFamily="34" charset="-120"/>
               </a:rPr>
-              <a:t>Train a model</a:t>
+              <a:t>Describe</a:t>
             </a:r>
             <a:endParaRPr lang="en-US" sz="1500" dirty="0"/>
           </a:p>
@@ -9942,7 +9942,7 @@
                 <a:ea typeface="Arial" pitchFamily="34" charset="-122"/>
                 <a:cs typeface="Arial" pitchFamily="34" charset="-120"/>
               </a:rPr>
-              <a:t>Map meaning</a:t>
+              <a:t>Build</a:t>
             </a:r>
             <a:endParaRPr lang="en-US" sz="1500" dirty="0"/>
           </a:p>
@@ -10046,7 +10046,7 @@
                 <a:ea typeface="Arial" pitchFamily="34" charset="-122"/>
                 <a:cs typeface="Arial" pitchFamily="34" charset="-120"/>
               </a:rPr>
-              <a:t>Noise to image</a:t>
+              <a:t>Test</a:t>
             </a:r>
             <a:endParaRPr lang="en-US" sz="1500" dirty="0"/>
           </a:p>
@@ -10150,7 +10150,7 @@
                 <a:ea typeface="Arial" pitchFamily="34" charset="-122"/>
                 <a:cs typeface="Arial" pitchFamily="34" charset="-120"/>
               </a:rPr>
-              <a:t>Hack the bot</a:t>
+              <a:t>Tweak</a:t>
             </a:r>
             <a:endParaRPr lang="en-US" sz="1500" dirty="0"/>
           </a:p>
@@ -10189,7 +10189,7 @@
                 <a:ea typeface="Arial" pitchFamily="34" charset="-122"/>
                 <a:cs typeface="Arial" pitchFamily="34" charset="-120"/>
               </a:rPr>
-              <a:t>Train it. Map it. Draw it. </a:t>
+              <a:t>Describe it. </a:t>
             </a:r>
             <a:pPr indent="0" marL="0">
               <a:buNone/>
@@ -10203,7 +10203,7 @@
                 <a:ea typeface="Arial" pitchFamily="34" charset="-122"/>
                 <a:cs typeface="Arial" pitchFamily="34" charset="-120"/>
               </a:rPr>
-              <a:t>Hack it.</a:t>
+              <a:t>Build it.</a:t>
             </a:r>
             <a:endParaRPr lang="en-US" sz="2400" dirty="0"/>
           </a:p>

</xml_diff>